<commit_message>
Haushaltsplaner als Ueberschrift ueber A1:C1
Co-Authored-By: Claude Sonnet 5.5 <noreply@anthropic.com>
Claude-Session: https://claude.ai/code/session_0139kriXJ67p3UvpR2gsSR9G
</commit_message>
<xml_diff>
--- a/videoslides/excel-haushaltsplaner-tabelle.pptx
+++ b/videoslides/excel-haushaltsplaner-tabelle.pptx
@@ -1512,7 +1512,7 @@
         <p:spPr>
           <a:xfrm>
             <a:off x="1238250" y="1384300"/>
-            <a:ext cx="10128250" cy="584200"/>
+            <a:ext cx="4000500" cy="584200"/>
           </a:xfrm>
           <a:prstGeom prst="rect">
             <a:avLst/>
@@ -1537,39 +1537,164 @@
         <p:spPr>
           <a:xfrm>
             <a:off x="1377950" y="1384300"/>
-            <a:ext cx="9937750" cy="584200"/>
-          </a:xfrm>
-          <a:prstGeom prst="rect">
-            <a:avLst/>
-          </a:prstGeom>
-          <a:noFill/>
-          <a:ln/>
-        </p:spPr>
-        <p:txBody>
-          <a:bodyPr wrap="none" lIns="0" tIns="0" rIns="0" bIns="0" rtlCol="0" anchor="ctr"/>
-          <a:lstStyle/>
-          <a:p>
-            <a:pPr indent="0" marL="0">
-              <a:buNone/>
-            </a:pPr>
-            <a:r>
-              <a:rPr lang="en-US" sz="1400" dirty="0">
-                <a:solidFill>
-                  <a:srgbClr val="333333"/>
-                </a:solidFill>
-                <a:latin typeface="Poppins" pitchFamily="34" charset="0"/>
-                <a:ea typeface="Poppins" pitchFamily="34" charset="-122"/>
-                <a:cs typeface="Poppins" pitchFamily="34" charset="-120"/>
-              </a:rPr>
-              <a:t>Haushaltsplaner (verbunden A1:C1, Größe 24)</a:t>
-            </a:r>
-            <a:endParaRPr lang="en-US" sz="1400" dirty="0"/>
-          </a:p>
-        </p:txBody>
-      </p:sp>
-      <p:sp>
-        <p:nvSpPr>
-          <p:cNvPr id="24" name="Zelle 2-0"/>
+            <a:ext cx="3810000" cy="584200"/>
+          </a:xfrm>
+          <a:prstGeom prst="rect">
+            <a:avLst/>
+          </a:prstGeom>
+          <a:noFill/>
+          <a:ln/>
+        </p:spPr>
+        <p:txBody>
+          <a:bodyPr wrap="none" lIns="0" tIns="0" rIns="0" bIns="0" rtlCol="0" anchor="ctr"/>
+          <a:lstStyle/>
+          <a:p>
+            <a:pPr indent="0" marL="0">
+              <a:buNone/>
+            </a:pPr>
+            <a:r>
+              <a:rPr lang="en-US" sz="2200" b="1" dirty="0">
+                <a:solidFill>
+                  <a:srgbClr val="36448A"/>
+                </a:solidFill>
+                <a:latin typeface="Poppins" pitchFamily="34" charset="0"/>
+                <a:ea typeface="Poppins" pitchFamily="34" charset="-122"/>
+                <a:cs typeface="Poppins" pitchFamily="34" charset="-120"/>
+              </a:rPr>
+              <a:t>Haushaltsplaner</a:t>
+            </a:r>
+            <a:endParaRPr lang="en-US" sz="2200" dirty="0"/>
+          </a:p>
+        </p:txBody>
+      </p:sp>
+      <p:sp>
+        <p:nvSpPr>
+          <p:cNvPr id="24" name="Zelle 1-4"/>
+          <p:cNvSpPr/>
+          <p:nvPr/>
+        </p:nvSpPr>
+        <p:spPr>
+          <a:xfrm>
+            <a:off x="5238750" y="1384300"/>
+            <a:ext cx="1079500" cy="584200"/>
+          </a:xfrm>
+          <a:prstGeom prst="rect">
+            <a:avLst/>
+          </a:prstGeom>
+          <a:solidFill>
+            <a:srgbClr val="FFFFFF"/>
+          </a:solidFill>
+          <a:ln w="12700">
+            <a:solidFill>
+              <a:srgbClr val="D3D8EE"/>
+            </a:solidFill>
+            <a:prstDash val="solid"/>
+          </a:ln>
+        </p:spPr>
+      </p:sp>
+      <p:sp>
+        <p:nvSpPr>
+          <p:cNvPr id="25" name="Zelle 1-5"/>
+          <p:cNvSpPr/>
+          <p:nvPr/>
+        </p:nvSpPr>
+        <p:spPr>
+          <a:xfrm>
+            <a:off x="6318250" y="1384300"/>
+            <a:ext cx="1079500" cy="584200"/>
+          </a:xfrm>
+          <a:prstGeom prst="rect">
+            <a:avLst/>
+          </a:prstGeom>
+          <a:solidFill>
+            <a:srgbClr val="FFFFFF"/>
+          </a:solidFill>
+          <a:ln w="12700">
+            <a:solidFill>
+              <a:srgbClr val="D3D8EE"/>
+            </a:solidFill>
+            <a:prstDash val="solid"/>
+          </a:ln>
+        </p:spPr>
+      </p:sp>
+      <p:sp>
+        <p:nvSpPr>
+          <p:cNvPr id="26" name="Zelle 1-6"/>
+          <p:cNvSpPr/>
+          <p:nvPr/>
+        </p:nvSpPr>
+        <p:spPr>
+          <a:xfrm>
+            <a:off x="7397750" y="1384300"/>
+            <a:ext cx="1079500" cy="584200"/>
+          </a:xfrm>
+          <a:prstGeom prst="rect">
+            <a:avLst/>
+          </a:prstGeom>
+          <a:solidFill>
+            <a:srgbClr val="FFFFFF"/>
+          </a:solidFill>
+          <a:ln w="12700">
+            <a:solidFill>
+              <a:srgbClr val="D3D8EE"/>
+            </a:solidFill>
+            <a:prstDash val="solid"/>
+          </a:ln>
+        </p:spPr>
+      </p:sp>
+      <p:sp>
+        <p:nvSpPr>
+          <p:cNvPr id="27" name="Zelle 1-7"/>
+          <p:cNvSpPr/>
+          <p:nvPr/>
+        </p:nvSpPr>
+        <p:spPr>
+          <a:xfrm>
+            <a:off x="8477250" y="1384300"/>
+            <a:ext cx="1079500" cy="584200"/>
+          </a:xfrm>
+          <a:prstGeom prst="rect">
+            <a:avLst/>
+          </a:prstGeom>
+          <a:solidFill>
+            <a:srgbClr val="FFFFFF"/>
+          </a:solidFill>
+          <a:ln w="12700">
+            <a:solidFill>
+              <a:srgbClr val="D3D8EE"/>
+            </a:solidFill>
+            <a:prstDash val="solid"/>
+          </a:ln>
+        </p:spPr>
+      </p:sp>
+      <p:sp>
+        <p:nvSpPr>
+          <p:cNvPr id="28" name="Zelle 1-8"/>
+          <p:cNvSpPr/>
+          <p:nvPr/>
+        </p:nvSpPr>
+        <p:spPr>
+          <a:xfrm>
+            <a:off x="9556750" y="1384300"/>
+            <a:ext cx="1809750" cy="584200"/>
+          </a:xfrm>
+          <a:prstGeom prst="rect">
+            <a:avLst/>
+          </a:prstGeom>
+          <a:solidFill>
+            <a:srgbClr val="FFFFFF"/>
+          </a:solidFill>
+          <a:ln w="12700">
+            <a:solidFill>
+              <a:srgbClr val="D3D8EE"/>
+            </a:solidFill>
+            <a:prstDash val="solid"/>
+          </a:ln>
+        </p:spPr>
+      </p:sp>
+      <p:sp>
+        <p:nvSpPr>
+          <p:cNvPr id="29" name="Zelle 2-0"/>
           <p:cNvSpPr/>
           <p:nvPr/>
         </p:nvSpPr>
@@ -1594,7 +1719,7 @@
       </p:sp>
       <p:sp>
         <p:nvSpPr>
-          <p:cNvPr id="25" name="Zelle 2-0 Text"/>
+          <p:cNvPr id="30" name="Zelle 2-0 Text"/>
           <p:cNvSpPr txBox="1"/>
           <p:nvPr/>
         </p:nvSpPr>
@@ -1633,7 +1758,7 @@
       </p:sp>
       <p:sp>
         <p:nvSpPr>
-          <p:cNvPr id="26" name="Zelle 2-1"/>
+          <p:cNvPr id="31" name="Zelle 2-1"/>
           <p:cNvSpPr/>
           <p:nvPr/>
         </p:nvSpPr>
@@ -1658,7 +1783,7 @@
       </p:sp>
       <p:sp>
         <p:nvSpPr>
-          <p:cNvPr id="27" name="Zelle 2-1 Text"/>
+          <p:cNvPr id="32" name="Zelle 2-1 Text"/>
           <p:cNvSpPr txBox="1"/>
           <p:nvPr/>
         </p:nvSpPr>
@@ -1697,7 +1822,7 @@
       </p:sp>
       <p:sp>
         <p:nvSpPr>
-          <p:cNvPr id="28" name="Zelle 2-2"/>
+          <p:cNvPr id="33" name="Zelle 2-2"/>
           <p:cNvSpPr/>
           <p:nvPr/>
         </p:nvSpPr>
@@ -1722,7 +1847,7 @@
       </p:sp>
       <p:sp>
         <p:nvSpPr>
-          <p:cNvPr id="29" name="Zelle 2-2 Text"/>
+          <p:cNvPr id="34" name="Zelle 2-2 Text"/>
           <p:cNvSpPr txBox="1"/>
           <p:nvPr/>
         </p:nvSpPr>
@@ -1761,7 +1886,7 @@
       </p:sp>
       <p:sp>
         <p:nvSpPr>
-          <p:cNvPr id="30" name="Zelle 2-3"/>
+          <p:cNvPr id="35" name="Zelle 2-3"/>
           <p:cNvSpPr/>
           <p:nvPr/>
         </p:nvSpPr>
@@ -1786,7 +1911,7 @@
       </p:sp>
       <p:sp>
         <p:nvSpPr>
-          <p:cNvPr id="31" name="Zelle 2-3 Text"/>
+          <p:cNvPr id="36" name="Zelle 2-3 Text"/>
           <p:cNvSpPr txBox="1"/>
           <p:nvPr/>
         </p:nvSpPr>
@@ -1825,7 +1950,7 @@
       </p:sp>
       <p:sp>
         <p:nvSpPr>
-          <p:cNvPr id="32" name="Zelle 2-4"/>
+          <p:cNvPr id="37" name="Zelle 2-4"/>
           <p:cNvSpPr/>
           <p:nvPr/>
         </p:nvSpPr>
@@ -1850,7 +1975,7 @@
       </p:sp>
       <p:sp>
         <p:nvSpPr>
-          <p:cNvPr id="33" name="Zelle 2-4 Text"/>
+          <p:cNvPr id="38" name="Zelle 2-4 Text"/>
           <p:cNvSpPr txBox="1"/>
           <p:nvPr/>
         </p:nvSpPr>
@@ -1889,7 +2014,7 @@
       </p:sp>
       <p:sp>
         <p:nvSpPr>
-          <p:cNvPr id="34" name="Zelle 2-5"/>
+          <p:cNvPr id="39" name="Zelle 2-5"/>
           <p:cNvSpPr/>
           <p:nvPr/>
         </p:nvSpPr>
@@ -1914,7 +2039,7 @@
       </p:sp>
       <p:sp>
         <p:nvSpPr>
-          <p:cNvPr id="35" name="Zelle 2-5 Text"/>
+          <p:cNvPr id="40" name="Zelle 2-5 Text"/>
           <p:cNvSpPr txBox="1"/>
           <p:nvPr/>
         </p:nvSpPr>
@@ -1953,7 +2078,7 @@
       </p:sp>
       <p:sp>
         <p:nvSpPr>
-          <p:cNvPr id="36" name="Zelle 2-6"/>
+          <p:cNvPr id="41" name="Zelle 2-6"/>
           <p:cNvSpPr/>
           <p:nvPr/>
         </p:nvSpPr>
@@ -1978,7 +2103,7 @@
       </p:sp>
       <p:sp>
         <p:nvSpPr>
-          <p:cNvPr id="37" name="Zelle 2-6 Text"/>
+          <p:cNvPr id="42" name="Zelle 2-6 Text"/>
           <p:cNvSpPr txBox="1"/>
           <p:nvPr/>
         </p:nvSpPr>
@@ -2017,7 +2142,7 @@
       </p:sp>
       <p:sp>
         <p:nvSpPr>
-          <p:cNvPr id="38" name="Zelle 2-7"/>
+          <p:cNvPr id="43" name="Zelle 2-7"/>
           <p:cNvSpPr/>
           <p:nvPr/>
         </p:nvSpPr>
@@ -2042,7 +2167,7 @@
       </p:sp>
       <p:sp>
         <p:nvSpPr>
-          <p:cNvPr id="39" name="Zelle 2-7 Text"/>
+          <p:cNvPr id="44" name="Zelle 2-7 Text"/>
           <p:cNvSpPr txBox="1"/>
           <p:nvPr/>
         </p:nvSpPr>
@@ -2081,7 +2206,7 @@
       </p:sp>
       <p:sp>
         <p:nvSpPr>
-          <p:cNvPr id="40" name="Zelle 2-8"/>
+          <p:cNvPr id="45" name="Zelle 2-8"/>
           <p:cNvSpPr/>
           <p:nvPr/>
         </p:nvSpPr>
@@ -2106,7 +2231,7 @@
       </p:sp>
       <p:sp>
         <p:nvSpPr>
-          <p:cNvPr id="41" name="Zelle 2-8 Text"/>
+          <p:cNvPr id="46" name="Zelle 2-8 Text"/>
           <p:cNvSpPr txBox="1"/>
           <p:nvPr/>
         </p:nvSpPr>
@@ -2145,7 +2270,7 @@
       </p:sp>
       <p:sp>
         <p:nvSpPr>
-          <p:cNvPr id="42" name="Zelle 3-0"/>
+          <p:cNvPr id="47" name="Zelle 3-0"/>
           <p:cNvSpPr/>
           <p:nvPr/>
         </p:nvSpPr>
@@ -2170,7 +2295,7 @@
       </p:sp>
       <p:sp>
         <p:nvSpPr>
-          <p:cNvPr id="43" name="Zelle 3-0 Text"/>
+          <p:cNvPr id="48" name="Zelle 3-0 Text"/>
           <p:cNvSpPr txBox="1"/>
           <p:nvPr/>
         </p:nvSpPr>
@@ -2209,7 +2334,7 @@
       </p:sp>
       <p:sp>
         <p:nvSpPr>
-          <p:cNvPr id="44" name="Zelle 3-1"/>
+          <p:cNvPr id="49" name="Zelle 3-1"/>
           <p:cNvSpPr/>
           <p:nvPr/>
         </p:nvSpPr>
@@ -2234,7 +2359,7 @@
       </p:sp>
       <p:sp>
         <p:nvSpPr>
-          <p:cNvPr id="45" name="Zelle 3-1 Text"/>
+          <p:cNvPr id="50" name="Zelle 3-1 Text"/>
           <p:cNvSpPr txBox="1"/>
           <p:nvPr/>
         </p:nvSpPr>
@@ -2273,7 +2398,7 @@
       </p:sp>
       <p:sp>
         <p:nvSpPr>
-          <p:cNvPr id="46" name="Zelle 3-2"/>
+          <p:cNvPr id="51" name="Zelle 3-2"/>
           <p:cNvSpPr/>
           <p:nvPr/>
         </p:nvSpPr>
@@ -2298,7 +2423,7 @@
       </p:sp>
       <p:sp>
         <p:nvSpPr>
-          <p:cNvPr id="47" name="Zelle 3-2 Text"/>
+          <p:cNvPr id="52" name="Zelle 3-2 Text"/>
           <p:cNvSpPr txBox="1"/>
           <p:nvPr/>
         </p:nvSpPr>
@@ -2337,7 +2462,7 @@
       </p:sp>
       <p:sp>
         <p:nvSpPr>
-          <p:cNvPr id="48" name="Zelle 3-3"/>
+          <p:cNvPr id="53" name="Zelle 3-3"/>
           <p:cNvSpPr/>
           <p:nvPr/>
         </p:nvSpPr>
@@ -2362,7 +2487,7 @@
       </p:sp>
       <p:sp>
         <p:nvSpPr>
-          <p:cNvPr id="49" name="Zelle 3-3 Text"/>
+          <p:cNvPr id="54" name="Zelle 3-3 Text"/>
           <p:cNvSpPr txBox="1"/>
           <p:nvPr/>
         </p:nvSpPr>
@@ -2401,7 +2526,7 @@
       </p:sp>
       <p:sp>
         <p:nvSpPr>
-          <p:cNvPr id="50" name="Zelle 3-4"/>
+          <p:cNvPr id="55" name="Zelle 3-4"/>
           <p:cNvSpPr/>
           <p:nvPr/>
         </p:nvSpPr>
@@ -2426,7 +2551,7 @@
       </p:sp>
       <p:sp>
         <p:nvSpPr>
-          <p:cNvPr id="51" name="Zelle 3-4 Text"/>
+          <p:cNvPr id="56" name="Zelle 3-4 Text"/>
           <p:cNvSpPr txBox="1"/>
           <p:nvPr/>
         </p:nvSpPr>
@@ -2465,7 +2590,7 @@
       </p:sp>
       <p:sp>
         <p:nvSpPr>
-          <p:cNvPr id="52" name="Zelle 3-5"/>
+          <p:cNvPr id="57" name="Zelle 3-5"/>
           <p:cNvSpPr/>
           <p:nvPr/>
         </p:nvSpPr>
@@ -2490,7 +2615,7 @@
       </p:sp>
       <p:sp>
         <p:nvSpPr>
-          <p:cNvPr id="53" name="Zelle 3-5 Text"/>
+          <p:cNvPr id="58" name="Zelle 3-5 Text"/>
           <p:cNvSpPr txBox="1"/>
           <p:nvPr/>
         </p:nvSpPr>
@@ -2529,7 +2654,7 @@
       </p:sp>
       <p:sp>
         <p:nvSpPr>
-          <p:cNvPr id="54" name="Zelle 3-6"/>
+          <p:cNvPr id="59" name="Zelle 3-6"/>
           <p:cNvSpPr/>
           <p:nvPr/>
         </p:nvSpPr>
@@ -2554,7 +2679,7 @@
       </p:sp>
       <p:sp>
         <p:nvSpPr>
-          <p:cNvPr id="55" name="Zelle 3-6 Text"/>
+          <p:cNvPr id="60" name="Zelle 3-6 Text"/>
           <p:cNvSpPr txBox="1"/>
           <p:nvPr/>
         </p:nvSpPr>
@@ -2593,7 +2718,7 @@
       </p:sp>
       <p:sp>
         <p:nvSpPr>
-          <p:cNvPr id="56" name="Zelle 3-7"/>
+          <p:cNvPr id="61" name="Zelle 3-7"/>
           <p:cNvSpPr/>
           <p:nvPr/>
         </p:nvSpPr>
@@ -2618,7 +2743,7 @@
       </p:sp>
       <p:sp>
         <p:nvSpPr>
-          <p:cNvPr id="57" name="Zelle 3-7 Text"/>
+          <p:cNvPr id="62" name="Zelle 3-7 Text"/>
           <p:cNvSpPr txBox="1"/>
           <p:nvPr/>
         </p:nvSpPr>
@@ -2657,7 +2782,7 @@
       </p:sp>
       <p:sp>
         <p:nvSpPr>
-          <p:cNvPr id="58" name="Zelle 3-8"/>
+          <p:cNvPr id="63" name="Zelle 3-8"/>
           <p:cNvSpPr/>
           <p:nvPr/>
         </p:nvSpPr>
@@ -2682,7 +2807,7 @@
       </p:sp>
       <p:sp>
         <p:nvSpPr>
-          <p:cNvPr id="59" name="Zelle 4-0"/>
+          <p:cNvPr id="64" name="Zelle 4-0"/>
           <p:cNvSpPr/>
           <p:nvPr/>
         </p:nvSpPr>
@@ -2707,7 +2832,7 @@
       </p:sp>
       <p:sp>
         <p:nvSpPr>
-          <p:cNvPr id="60" name="Zelle 4-0 Text"/>
+          <p:cNvPr id="65" name="Zelle 4-0 Text"/>
           <p:cNvSpPr txBox="1"/>
           <p:nvPr/>
         </p:nvSpPr>
@@ -2746,7 +2871,7 @@
       </p:sp>
       <p:sp>
         <p:nvSpPr>
-          <p:cNvPr id="61" name="Zelle 4-1"/>
+          <p:cNvPr id="66" name="Zelle 4-1"/>
           <p:cNvSpPr/>
           <p:nvPr/>
         </p:nvSpPr>
@@ -2771,7 +2896,7 @@
       </p:sp>
       <p:sp>
         <p:nvSpPr>
-          <p:cNvPr id="62" name="Zelle 4-1 Text"/>
+          <p:cNvPr id="67" name="Zelle 4-1 Text"/>
           <p:cNvSpPr txBox="1"/>
           <p:nvPr/>
         </p:nvSpPr>
@@ -2810,7 +2935,7 @@
       </p:sp>
       <p:sp>
         <p:nvSpPr>
-          <p:cNvPr id="63" name="Zelle 4-2"/>
+          <p:cNvPr id="68" name="Zelle 4-2"/>
           <p:cNvSpPr/>
           <p:nvPr/>
         </p:nvSpPr>
@@ -2835,7 +2960,7 @@
       </p:sp>
       <p:sp>
         <p:nvSpPr>
-          <p:cNvPr id="64" name="Zelle 4-2 Text"/>
+          <p:cNvPr id="69" name="Zelle 4-2 Text"/>
           <p:cNvSpPr txBox="1"/>
           <p:nvPr/>
         </p:nvSpPr>
@@ -2874,7 +2999,7 @@
       </p:sp>
       <p:sp>
         <p:nvSpPr>
-          <p:cNvPr id="65" name="Zelle 4-3"/>
+          <p:cNvPr id="70" name="Zelle 4-3"/>
           <p:cNvSpPr/>
           <p:nvPr/>
         </p:nvSpPr>
@@ -2899,7 +3024,7 @@
       </p:sp>
       <p:sp>
         <p:nvSpPr>
-          <p:cNvPr id="66" name="Zelle 4-3 Text"/>
+          <p:cNvPr id="71" name="Zelle 4-3 Text"/>
           <p:cNvSpPr txBox="1"/>
           <p:nvPr/>
         </p:nvSpPr>
@@ -2938,7 +3063,7 @@
       </p:sp>
       <p:sp>
         <p:nvSpPr>
-          <p:cNvPr id="67" name="Zelle 4-4"/>
+          <p:cNvPr id="72" name="Zelle 4-4"/>
           <p:cNvSpPr/>
           <p:nvPr/>
         </p:nvSpPr>
@@ -2963,7 +3088,7 @@
       </p:sp>
       <p:sp>
         <p:nvSpPr>
-          <p:cNvPr id="68" name="Zelle 4-4 Text"/>
+          <p:cNvPr id="73" name="Zelle 4-4 Text"/>
           <p:cNvSpPr txBox="1"/>
           <p:nvPr/>
         </p:nvSpPr>
@@ -3002,7 +3127,7 @@
       </p:sp>
       <p:sp>
         <p:nvSpPr>
-          <p:cNvPr id="69" name="Zelle 4-5"/>
+          <p:cNvPr id="74" name="Zelle 4-5"/>
           <p:cNvSpPr/>
           <p:nvPr/>
         </p:nvSpPr>
@@ -3027,7 +3152,7 @@
       </p:sp>
       <p:sp>
         <p:nvSpPr>
-          <p:cNvPr id="70" name="Zelle 4-5 Text"/>
+          <p:cNvPr id="75" name="Zelle 4-5 Text"/>
           <p:cNvSpPr txBox="1"/>
           <p:nvPr/>
         </p:nvSpPr>
@@ -3066,7 +3191,7 @@
       </p:sp>
       <p:sp>
         <p:nvSpPr>
-          <p:cNvPr id="71" name="Zelle 4-6"/>
+          <p:cNvPr id="76" name="Zelle 4-6"/>
           <p:cNvSpPr/>
           <p:nvPr/>
         </p:nvSpPr>
@@ -3091,7 +3216,7 @@
       </p:sp>
       <p:sp>
         <p:nvSpPr>
-          <p:cNvPr id="72" name="Zelle 4-6 Text"/>
+          <p:cNvPr id="77" name="Zelle 4-6 Text"/>
           <p:cNvSpPr txBox="1"/>
           <p:nvPr/>
         </p:nvSpPr>
@@ -3130,7 +3255,7 @@
       </p:sp>
       <p:sp>
         <p:nvSpPr>
-          <p:cNvPr id="73" name="Zelle 4-7"/>
+          <p:cNvPr id="78" name="Zelle 4-7"/>
           <p:cNvSpPr/>
           <p:nvPr/>
         </p:nvSpPr>
@@ -3155,7 +3280,7 @@
       </p:sp>
       <p:sp>
         <p:nvSpPr>
-          <p:cNvPr id="74" name="Zelle 4-7 Text"/>
+          <p:cNvPr id="79" name="Zelle 4-7 Text"/>
           <p:cNvSpPr txBox="1"/>
           <p:nvPr/>
         </p:nvSpPr>
@@ -3194,7 +3319,7 @@
       </p:sp>
       <p:sp>
         <p:nvSpPr>
-          <p:cNvPr id="75" name="Zelle 4-8"/>
+          <p:cNvPr id="80" name="Zelle 4-8"/>
           <p:cNvSpPr/>
           <p:nvPr/>
         </p:nvSpPr>
@@ -3219,7 +3344,7 @@
       </p:sp>
       <p:sp>
         <p:nvSpPr>
-          <p:cNvPr id="76" name="Zelle 5-0"/>
+          <p:cNvPr id="81" name="Zelle 5-0"/>
           <p:cNvSpPr/>
           <p:nvPr/>
         </p:nvSpPr>
@@ -3244,7 +3369,7 @@
       </p:sp>
       <p:sp>
         <p:nvSpPr>
-          <p:cNvPr id="77" name="Zelle 5-0 Text"/>
+          <p:cNvPr id="82" name="Zelle 5-0 Text"/>
           <p:cNvSpPr txBox="1"/>
           <p:nvPr/>
         </p:nvSpPr>
@@ -3283,7 +3408,7 @@
       </p:sp>
       <p:sp>
         <p:nvSpPr>
-          <p:cNvPr id="78" name="Zelle 5-1"/>
+          <p:cNvPr id="83" name="Zelle 5-1"/>
           <p:cNvSpPr/>
           <p:nvPr/>
         </p:nvSpPr>
@@ -3308,7 +3433,7 @@
       </p:sp>
       <p:sp>
         <p:nvSpPr>
-          <p:cNvPr id="79" name="Zelle 5-1 Text"/>
+          <p:cNvPr id="84" name="Zelle 5-1 Text"/>
           <p:cNvSpPr txBox="1"/>
           <p:nvPr/>
         </p:nvSpPr>
@@ -3347,7 +3472,7 @@
       </p:sp>
       <p:sp>
         <p:nvSpPr>
-          <p:cNvPr id="80" name="Zelle 5-2"/>
+          <p:cNvPr id="85" name="Zelle 5-2"/>
           <p:cNvSpPr/>
           <p:nvPr/>
         </p:nvSpPr>
@@ -3372,7 +3497,7 @@
       </p:sp>
       <p:sp>
         <p:nvSpPr>
-          <p:cNvPr id="81" name="Zelle 5-2 Text"/>
+          <p:cNvPr id="86" name="Zelle 5-2 Text"/>
           <p:cNvSpPr txBox="1"/>
           <p:nvPr/>
         </p:nvSpPr>
@@ -3411,7 +3536,7 @@
       </p:sp>
       <p:sp>
         <p:nvSpPr>
-          <p:cNvPr id="82" name="Zelle 5-3"/>
+          <p:cNvPr id="87" name="Zelle 5-3"/>
           <p:cNvSpPr/>
           <p:nvPr/>
         </p:nvSpPr>
@@ -3436,7 +3561,7 @@
       </p:sp>
       <p:sp>
         <p:nvSpPr>
-          <p:cNvPr id="83" name="Zelle 5-3 Text"/>
+          <p:cNvPr id="88" name="Zelle 5-3 Text"/>
           <p:cNvSpPr txBox="1"/>
           <p:nvPr/>
         </p:nvSpPr>
@@ -3475,7 +3600,7 @@
       </p:sp>
       <p:sp>
         <p:nvSpPr>
-          <p:cNvPr id="84" name="Zelle 5-4"/>
+          <p:cNvPr id="89" name="Zelle 5-4"/>
           <p:cNvSpPr/>
           <p:nvPr/>
         </p:nvSpPr>
@@ -3500,7 +3625,7 @@
       </p:sp>
       <p:sp>
         <p:nvSpPr>
-          <p:cNvPr id="85" name="Zelle 5-4 Text"/>
+          <p:cNvPr id="90" name="Zelle 5-4 Text"/>
           <p:cNvSpPr txBox="1"/>
           <p:nvPr/>
         </p:nvSpPr>
@@ -3539,7 +3664,7 @@
       </p:sp>
       <p:sp>
         <p:nvSpPr>
-          <p:cNvPr id="86" name="Zelle 5-5"/>
+          <p:cNvPr id="91" name="Zelle 5-5"/>
           <p:cNvSpPr/>
           <p:nvPr/>
         </p:nvSpPr>
@@ -3564,7 +3689,7 @@
       </p:sp>
       <p:sp>
         <p:nvSpPr>
-          <p:cNvPr id="87" name="Zelle 5-5 Text"/>
+          <p:cNvPr id="92" name="Zelle 5-5 Text"/>
           <p:cNvSpPr txBox="1"/>
           <p:nvPr/>
         </p:nvSpPr>
@@ -3603,7 +3728,7 @@
       </p:sp>
       <p:sp>
         <p:nvSpPr>
-          <p:cNvPr id="88" name="Zelle 5-6"/>
+          <p:cNvPr id="93" name="Zelle 5-6"/>
           <p:cNvSpPr/>
           <p:nvPr/>
         </p:nvSpPr>
@@ -3628,7 +3753,7 @@
       </p:sp>
       <p:sp>
         <p:nvSpPr>
-          <p:cNvPr id="89" name="Zelle 5-6 Text"/>
+          <p:cNvPr id="94" name="Zelle 5-6 Text"/>
           <p:cNvSpPr txBox="1"/>
           <p:nvPr/>
         </p:nvSpPr>
@@ -3667,7 +3792,7 @@
       </p:sp>
       <p:sp>
         <p:nvSpPr>
-          <p:cNvPr id="90" name="Zelle 5-7"/>
+          <p:cNvPr id="95" name="Zelle 5-7"/>
           <p:cNvSpPr/>
           <p:nvPr/>
         </p:nvSpPr>
@@ -3692,7 +3817,7 @@
       </p:sp>
       <p:sp>
         <p:nvSpPr>
-          <p:cNvPr id="91" name="Zelle 5-7 Text"/>
+          <p:cNvPr id="96" name="Zelle 5-7 Text"/>
           <p:cNvSpPr txBox="1"/>
           <p:nvPr/>
         </p:nvSpPr>
@@ -3731,7 +3856,7 @@
       </p:sp>
       <p:sp>
         <p:nvSpPr>
-          <p:cNvPr id="92" name="Zelle 5-8"/>
+          <p:cNvPr id="97" name="Zelle 5-8"/>
           <p:cNvSpPr/>
           <p:nvPr/>
         </p:nvSpPr>
@@ -3756,7 +3881,7 @@
       </p:sp>
       <p:sp>
         <p:nvSpPr>
-          <p:cNvPr id="93" name="Zelle 6-0"/>
+          <p:cNvPr id="98" name="Zelle 6-0"/>
           <p:cNvSpPr/>
           <p:nvPr/>
         </p:nvSpPr>
@@ -3781,7 +3906,7 @@
       </p:sp>
       <p:sp>
         <p:nvSpPr>
-          <p:cNvPr id="94" name="Zelle 6-0 Text"/>
+          <p:cNvPr id="99" name="Zelle 6-0 Text"/>
           <p:cNvSpPr txBox="1"/>
           <p:nvPr/>
         </p:nvSpPr>
@@ -3820,7 +3945,7 @@
       </p:sp>
       <p:sp>
         <p:nvSpPr>
-          <p:cNvPr id="95" name="Zelle 6-1"/>
+          <p:cNvPr id="100" name="Zelle 6-1"/>
           <p:cNvSpPr/>
           <p:nvPr/>
         </p:nvSpPr>
@@ -3845,7 +3970,7 @@
       </p:sp>
       <p:sp>
         <p:nvSpPr>
-          <p:cNvPr id="96" name="Zelle 6-1 Text"/>
+          <p:cNvPr id="101" name="Zelle 6-1 Text"/>
           <p:cNvSpPr txBox="1"/>
           <p:nvPr/>
         </p:nvSpPr>
@@ -3884,7 +4009,7 @@
       </p:sp>
       <p:sp>
         <p:nvSpPr>
-          <p:cNvPr id="97" name="Zelle 6-2"/>
+          <p:cNvPr id="102" name="Zelle 6-2"/>
           <p:cNvSpPr/>
           <p:nvPr/>
         </p:nvSpPr>
@@ -3909,7 +4034,7 @@
       </p:sp>
       <p:sp>
         <p:nvSpPr>
-          <p:cNvPr id="98" name="Zelle 6-2 Text"/>
+          <p:cNvPr id="103" name="Zelle 6-2 Text"/>
           <p:cNvSpPr txBox="1"/>
           <p:nvPr/>
         </p:nvSpPr>
@@ -3948,7 +4073,7 @@
       </p:sp>
       <p:sp>
         <p:nvSpPr>
-          <p:cNvPr id="99" name="Zelle 6-3"/>
+          <p:cNvPr id="104" name="Zelle 6-3"/>
           <p:cNvSpPr/>
           <p:nvPr/>
         </p:nvSpPr>
@@ -3973,7 +4098,7 @@
       </p:sp>
       <p:sp>
         <p:nvSpPr>
-          <p:cNvPr id="100" name="Zelle 6-3 Text"/>
+          <p:cNvPr id="105" name="Zelle 6-3 Text"/>
           <p:cNvSpPr txBox="1"/>
           <p:nvPr/>
         </p:nvSpPr>
@@ -4012,7 +4137,7 @@
       </p:sp>
       <p:sp>
         <p:nvSpPr>
-          <p:cNvPr id="101" name="Zelle 6-4"/>
+          <p:cNvPr id="106" name="Zelle 6-4"/>
           <p:cNvSpPr/>
           <p:nvPr/>
         </p:nvSpPr>
@@ -4037,7 +4162,7 @@
       </p:sp>
       <p:sp>
         <p:nvSpPr>
-          <p:cNvPr id="102" name="Zelle 6-4 Text"/>
+          <p:cNvPr id="107" name="Zelle 6-4 Text"/>
           <p:cNvSpPr txBox="1"/>
           <p:nvPr/>
         </p:nvSpPr>
@@ -4076,7 +4201,7 @@
       </p:sp>
       <p:sp>
         <p:nvSpPr>
-          <p:cNvPr id="103" name="Zelle 6-5"/>
+          <p:cNvPr id="108" name="Zelle 6-5"/>
           <p:cNvSpPr/>
           <p:nvPr/>
         </p:nvSpPr>
@@ -4101,7 +4226,7 @@
       </p:sp>
       <p:sp>
         <p:nvSpPr>
-          <p:cNvPr id="104" name="Zelle 6-5 Text"/>
+          <p:cNvPr id="109" name="Zelle 6-5 Text"/>
           <p:cNvSpPr txBox="1"/>
           <p:nvPr/>
         </p:nvSpPr>
@@ -4140,7 +4265,7 @@
       </p:sp>
       <p:sp>
         <p:nvSpPr>
-          <p:cNvPr id="105" name="Zelle 6-6"/>
+          <p:cNvPr id="110" name="Zelle 6-6"/>
           <p:cNvSpPr/>
           <p:nvPr/>
         </p:nvSpPr>
@@ -4165,7 +4290,7 @@
       </p:sp>
       <p:sp>
         <p:nvSpPr>
-          <p:cNvPr id="106" name="Zelle 6-6 Text"/>
+          <p:cNvPr id="111" name="Zelle 6-6 Text"/>
           <p:cNvSpPr txBox="1"/>
           <p:nvPr/>
         </p:nvSpPr>
@@ -4204,7 +4329,7 @@
       </p:sp>
       <p:sp>
         <p:nvSpPr>
-          <p:cNvPr id="107" name="Zelle 6-7"/>
+          <p:cNvPr id="112" name="Zelle 6-7"/>
           <p:cNvSpPr/>
           <p:nvPr/>
         </p:nvSpPr>
@@ -4229,7 +4354,7 @@
       </p:sp>
       <p:sp>
         <p:nvSpPr>
-          <p:cNvPr id="108" name="Zelle 6-7 Text"/>
+          <p:cNvPr id="113" name="Zelle 6-7 Text"/>
           <p:cNvSpPr txBox="1"/>
           <p:nvPr/>
         </p:nvSpPr>
@@ -4268,7 +4393,7 @@
       </p:sp>
       <p:sp>
         <p:nvSpPr>
-          <p:cNvPr id="109" name="Zelle 6-8"/>
+          <p:cNvPr id="114" name="Zelle 6-8"/>
           <p:cNvSpPr/>
           <p:nvPr/>
         </p:nvSpPr>
@@ -4293,7 +4418,7 @@
       </p:sp>
       <p:sp>
         <p:nvSpPr>
-          <p:cNvPr id="110" name="Zelle 7-0"/>
+          <p:cNvPr id="115" name="Zelle 7-0"/>
           <p:cNvSpPr/>
           <p:nvPr/>
         </p:nvSpPr>
@@ -4318,7 +4443,7 @@
       </p:sp>
       <p:sp>
         <p:nvSpPr>
-          <p:cNvPr id="111" name="Zelle 7-0 Text"/>
+          <p:cNvPr id="116" name="Zelle 7-0 Text"/>
           <p:cNvSpPr txBox="1"/>
           <p:nvPr/>
         </p:nvSpPr>
@@ -4357,7 +4482,7 @@
       </p:sp>
       <p:sp>
         <p:nvSpPr>
-          <p:cNvPr id="112" name="Zelle 7-1"/>
+          <p:cNvPr id="117" name="Zelle 7-1"/>
           <p:cNvSpPr/>
           <p:nvPr/>
         </p:nvSpPr>
@@ -4382,7 +4507,7 @@
       </p:sp>
       <p:sp>
         <p:nvSpPr>
-          <p:cNvPr id="113" name="Zelle 7-1 Text"/>
+          <p:cNvPr id="118" name="Zelle 7-1 Text"/>
           <p:cNvSpPr txBox="1"/>
           <p:nvPr/>
         </p:nvSpPr>
@@ -4421,7 +4546,7 @@
       </p:sp>
       <p:sp>
         <p:nvSpPr>
-          <p:cNvPr id="114" name="Zelle 7-2"/>
+          <p:cNvPr id="119" name="Zelle 7-2"/>
           <p:cNvSpPr/>
           <p:nvPr/>
         </p:nvSpPr>
@@ -4446,7 +4571,7 @@
       </p:sp>
       <p:sp>
         <p:nvSpPr>
-          <p:cNvPr id="115" name="Zelle 7-2 Text"/>
+          <p:cNvPr id="120" name="Zelle 7-2 Text"/>
           <p:cNvSpPr txBox="1"/>
           <p:nvPr/>
         </p:nvSpPr>
@@ -4485,7 +4610,7 @@
       </p:sp>
       <p:sp>
         <p:nvSpPr>
-          <p:cNvPr id="116" name="Zelle 7-3"/>
+          <p:cNvPr id="121" name="Zelle 7-3"/>
           <p:cNvSpPr/>
           <p:nvPr/>
         </p:nvSpPr>
@@ -4510,7 +4635,7 @@
       </p:sp>
       <p:sp>
         <p:nvSpPr>
-          <p:cNvPr id="117" name="Zelle 7-3 Text"/>
+          <p:cNvPr id="122" name="Zelle 7-3 Text"/>
           <p:cNvSpPr txBox="1"/>
           <p:nvPr/>
         </p:nvSpPr>
@@ -4549,7 +4674,7 @@
       </p:sp>
       <p:sp>
         <p:nvSpPr>
-          <p:cNvPr id="118" name="Zelle 7-4"/>
+          <p:cNvPr id="123" name="Zelle 7-4"/>
           <p:cNvSpPr/>
           <p:nvPr/>
         </p:nvSpPr>
@@ -4574,7 +4699,7 @@
       </p:sp>
       <p:sp>
         <p:nvSpPr>
-          <p:cNvPr id="119" name="Zelle 7-4 Text"/>
+          <p:cNvPr id="124" name="Zelle 7-4 Text"/>
           <p:cNvSpPr txBox="1"/>
           <p:nvPr/>
         </p:nvSpPr>
@@ -4613,7 +4738,7 @@
       </p:sp>
       <p:sp>
         <p:nvSpPr>
-          <p:cNvPr id="120" name="Zelle 7-5"/>
+          <p:cNvPr id="125" name="Zelle 7-5"/>
           <p:cNvSpPr/>
           <p:nvPr/>
         </p:nvSpPr>
@@ -4638,7 +4763,7 @@
       </p:sp>
       <p:sp>
         <p:nvSpPr>
-          <p:cNvPr id="121" name="Zelle 7-5 Text"/>
+          <p:cNvPr id="126" name="Zelle 7-5 Text"/>
           <p:cNvSpPr txBox="1"/>
           <p:nvPr/>
         </p:nvSpPr>
@@ -4677,7 +4802,7 @@
       </p:sp>
       <p:sp>
         <p:nvSpPr>
-          <p:cNvPr id="122" name="Zelle 7-6"/>
+          <p:cNvPr id="127" name="Zelle 7-6"/>
           <p:cNvSpPr/>
           <p:nvPr/>
         </p:nvSpPr>
@@ -4702,7 +4827,7 @@
       </p:sp>
       <p:sp>
         <p:nvSpPr>
-          <p:cNvPr id="123" name="Zelle 7-6 Text"/>
+          <p:cNvPr id="128" name="Zelle 7-6 Text"/>
           <p:cNvSpPr txBox="1"/>
           <p:nvPr/>
         </p:nvSpPr>
@@ -4741,7 +4866,7 @@
       </p:sp>
       <p:sp>
         <p:nvSpPr>
-          <p:cNvPr id="124" name="Zelle 7-7"/>
+          <p:cNvPr id="129" name="Zelle 7-7"/>
           <p:cNvSpPr/>
           <p:nvPr/>
         </p:nvSpPr>
@@ -4766,7 +4891,7 @@
       </p:sp>
       <p:sp>
         <p:nvSpPr>
-          <p:cNvPr id="125" name="Zelle 7-7 Text"/>
+          <p:cNvPr id="130" name="Zelle 7-7 Text"/>
           <p:cNvSpPr txBox="1"/>
           <p:nvPr/>
         </p:nvSpPr>
@@ -4805,7 +4930,7 @@
       </p:sp>
       <p:sp>
         <p:nvSpPr>
-          <p:cNvPr id="126" name="Zelle 7-8"/>
+          <p:cNvPr id="131" name="Zelle 7-8"/>
           <p:cNvSpPr/>
           <p:nvPr/>
         </p:nvSpPr>
@@ -4830,7 +4955,7 @@
       </p:sp>
       <p:sp>
         <p:nvSpPr>
-          <p:cNvPr id="127" name="Zelle 8-0"/>
+          <p:cNvPr id="132" name="Zelle 8-0"/>
           <p:cNvSpPr/>
           <p:nvPr/>
         </p:nvSpPr>
@@ -4855,7 +4980,7 @@
       </p:sp>
       <p:sp>
         <p:nvSpPr>
-          <p:cNvPr id="128" name="Zelle 8-0 Text"/>
+          <p:cNvPr id="133" name="Zelle 8-0 Text"/>
           <p:cNvSpPr txBox="1"/>
           <p:nvPr/>
         </p:nvSpPr>
@@ -4894,7 +5019,7 @@
       </p:sp>
       <p:sp>
         <p:nvSpPr>
-          <p:cNvPr id="129" name="Zelle 8-1"/>
+          <p:cNvPr id="134" name="Zelle 8-1"/>
           <p:cNvSpPr/>
           <p:nvPr/>
         </p:nvSpPr>
@@ -4919,7 +5044,7 @@
       </p:sp>
       <p:sp>
         <p:nvSpPr>
-          <p:cNvPr id="130" name="Zelle 8-1 Text"/>
+          <p:cNvPr id="135" name="Zelle 8-1 Text"/>
           <p:cNvSpPr txBox="1"/>
           <p:nvPr/>
         </p:nvSpPr>
@@ -4958,7 +5083,7 @@
       </p:sp>
       <p:sp>
         <p:nvSpPr>
-          <p:cNvPr id="131" name="Zelle 8-2"/>
+          <p:cNvPr id="136" name="Zelle 8-2"/>
           <p:cNvSpPr/>
           <p:nvPr/>
         </p:nvSpPr>
@@ -4983,7 +5108,7 @@
       </p:sp>
       <p:sp>
         <p:nvSpPr>
-          <p:cNvPr id="132" name="Zelle 8-3"/>
+          <p:cNvPr id="137" name="Zelle 8-3"/>
           <p:cNvSpPr/>
           <p:nvPr/>
         </p:nvSpPr>
@@ -5008,7 +5133,7 @@
       </p:sp>
       <p:sp>
         <p:nvSpPr>
-          <p:cNvPr id="133" name="Zelle 8-4"/>
+          <p:cNvPr id="138" name="Zelle 8-4"/>
           <p:cNvSpPr/>
           <p:nvPr/>
         </p:nvSpPr>
@@ -5033,7 +5158,7 @@
       </p:sp>
       <p:sp>
         <p:nvSpPr>
-          <p:cNvPr id="134" name="Zelle 8-5"/>
+          <p:cNvPr id="139" name="Zelle 8-5"/>
           <p:cNvSpPr/>
           <p:nvPr/>
         </p:nvSpPr>
@@ -5058,7 +5183,7 @@
       </p:sp>
       <p:sp>
         <p:nvSpPr>
-          <p:cNvPr id="135" name="Zelle 8-6"/>
+          <p:cNvPr id="140" name="Zelle 8-6"/>
           <p:cNvSpPr/>
           <p:nvPr/>
         </p:nvSpPr>
@@ -5083,7 +5208,7 @@
       </p:sp>
       <p:sp>
         <p:nvSpPr>
-          <p:cNvPr id="136" name="Zelle 8-7"/>
+          <p:cNvPr id="141" name="Zelle 8-7"/>
           <p:cNvSpPr/>
           <p:nvPr/>
         </p:nvSpPr>
@@ -5108,7 +5233,7 @@
       </p:sp>
       <p:sp>
         <p:nvSpPr>
-          <p:cNvPr id="137" name="Zelle 8-8"/>
+          <p:cNvPr id="142" name="Zelle 8-8"/>
           <p:cNvSpPr/>
           <p:nvPr/>
         </p:nvSpPr>

</xml_diff>